<commit_message>
Add LOD post-RAM analysis tooling
</commit_message>
<xml_diff>
--- a/plans/0609_pre/0609_rod_dataset_preparation_page1.pptx
+++ b/plans/0609_pre/0609_rod_dataset_preparation_page1.pptx
@@ -7664,7 +7664,7 @@
           <a:p>
             <a:pPr algn="l"/>
             <a:r>
-              <a:rPr sz="860" b="1">
+              <a:rPr sz="860" b="0">
                 <a:solidFill>
                   <a:srgbClr val="6B7280"/>
                 </a:solidFill>
@@ -7909,7 +7909,7 @@
           <a:p>
             <a:pPr algn="l"/>
             <a:r>
-              <a:rPr sz="860" b="1">
+              <a:rPr sz="860" b="0">
                 <a:solidFill>
                   <a:srgbClr val="2563EB"/>
                 </a:solidFill>
@@ -8154,13 +8154,13 @@
           <a:p>
             <a:pPr algn="l"/>
             <a:r>
-              <a:rPr sz="860" b="1">
-                <a:solidFill>
-                  <a:srgbClr val="2563EB"/>
-                </a:solidFill>
-                <a:latin typeface="Noto Sans CJK SC"/>
-              </a:rPr>
-              <a:t>0605_0139</a:t>
+              <a:rPr sz="860" b="0">
+                <a:solidFill>
+                  <a:srgbClr val="0F766E"/>
+                </a:solidFill>
+                <a:latin typeface="Noto Sans CJK SC"/>
+              </a:rPr>
+              <a:t>0606_1348 R1</a:t>
             </a:r>
           </a:p>
         </p:txBody>
@@ -8195,7 +8195,7 @@
                 </a:solidFill>
                 <a:latin typeface="Noto Sans CJK SC"/>
               </a:rPr>
-              <a:t>RGB</a:t>
+              <a:t>RAW</a:t>
             </a:r>
           </a:p>
         </p:txBody>
@@ -8230,7 +8230,7 @@
                 </a:solidFill>
                 <a:latin typeface="Noto Sans CJK SC"/>
               </a:rPr>
-              <a:t>RGB LoRA tap + decoder</a:t>
+              <a:t>RAW-RAM decoder repl</a:t>
             </a:r>
           </a:p>
         </p:txBody>
@@ -8265,7 +8265,7 @@
                 </a:solidFill>
                 <a:latin typeface="Noto Sans CJK SC"/>
               </a:rPr>
-              <a:t>0.8251</a:t>
+              <a:t>0.8412</a:t>
             </a:r>
           </a:p>
         </p:txBody>
@@ -8300,7 +8300,7 @@
                 </a:solidFill>
                 <a:latin typeface="Noto Sans CJK SC"/>
               </a:rPr>
-              <a:t>e7</a:t>
+              <a:t>e6</a:t>
             </a:r>
           </a:p>
         </p:txBody>
@@ -8335,7 +8335,7 @@
                 </a:solidFill>
                 <a:latin typeface="Noto Sans CJK SC"/>
               </a:rPr>
-              <a:t>8.3252</a:t>
+              <a:t>5.5653</a:t>
             </a:r>
           </a:p>
         </p:txBody>
@@ -8399,13 +8399,13 @@
           <a:p>
             <a:pPr algn="l"/>
             <a:r>
-              <a:rPr sz="860" b="1">
-                <a:solidFill>
-                  <a:srgbClr val="16A34A"/>
-                </a:solidFill>
-                <a:latin typeface="Noto Sans CJK SC"/>
-              </a:rPr>
-              <a:t>0605_0730</a:t>
+              <a:rPr sz="860" b="0">
+                <a:solidFill>
+                  <a:srgbClr val="2563EB"/>
+                </a:solidFill>
+                <a:latin typeface="Noto Sans CJK SC"/>
+              </a:rPr>
+              <a:t>0605_0139</a:t>
             </a:r>
           </a:p>
         </p:txBody>
@@ -8475,7 +8475,7 @@
                 </a:solidFill>
                 <a:latin typeface="Noto Sans CJK SC"/>
               </a:rPr>
-              <a:t>RGB full backbone LLRD</a:t>
+              <a:t>RGB LoRA tap + decoder</a:t>
             </a:r>
           </a:p>
         </p:txBody>
@@ -8510,7 +8510,7 @@
                 </a:solidFill>
                 <a:latin typeface="Noto Sans CJK SC"/>
               </a:rPr>
-              <a:t>0.8483</a:t>
+              <a:t>0.8251</a:t>
             </a:r>
           </a:p>
         </p:txBody>
@@ -8545,7 +8545,7 @@
                 </a:solidFill>
                 <a:latin typeface="Noto Sans CJK SC"/>
               </a:rPr>
-              <a:t>e8</a:t>
+              <a:t>e7</a:t>
             </a:r>
           </a:p>
         </p:txBody>
@@ -8580,7 +8580,7 @@
                 </a:solidFill>
                 <a:latin typeface="Noto Sans CJK SC"/>
               </a:rPr>
-              <a:t>5.8880</a:t>
+              <a:t>8.3252</a:t>
             </a:r>
           </a:p>
         </p:txBody>
@@ -8644,13 +8644,13 @@
           <a:p>
             <a:pPr algn="l"/>
             <a:r>
-              <a:rPr sz="860" b="1">
+              <a:rPr sz="860" b="0">
                 <a:solidFill>
                   <a:srgbClr val="0F766E"/>
                 </a:solidFill>
                 <a:latin typeface="Noto Sans CJK SC"/>
               </a:rPr>
-              <a:t>0606_1348 R1</a:t>
+              <a:t>0606_1348 R2</a:t>
             </a:r>
           </a:p>
         </p:txBody>
@@ -8720,7 +8720,7 @@
                 </a:solidFill>
                 <a:latin typeface="Noto Sans CJK SC"/>
               </a:rPr>
-              <a:t>RAW-RAM decoder repl</a:t>
+              <a:t>RAW-RAM LoRA repl</a:t>
             </a:r>
           </a:p>
         </p:txBody>
@@ -8755,7 +8755,7 @@
                 </a:solidFill>
                 <a:latin typeface="Noto Sans CJK SC"/>
               </a:rPr>
-              <a:t>0.8412</a:t>
+              <a:t>0.8437</a:t>
             </a:r>
           </a:p>
         </p:txBody>
@@ -8790,7 +8790,7 @@
                 </a:solidFill>
                 <a:latin typeface="Noto Sans CJK SC"/>
               </a:rPr>
-              <a:t>e6</a:t>
+              <a:t>e3</a:t>
             </a:r>
           </a:p>
         </p:txBody>
@@ -8825,7 +8825,7 @@
                 </a:solidFill>
                 <a:latin typeface="Noto Sans CJK SC"/>
               </a:rPr>
-              <a:t>5.5653</a:t>
+              <a:t>6.8383</a:t>
             </a:r>
           </a:p>
         </p:txBody>
@@ -8889,13 +8889,13 @@
           <a:p>
             <a:pPr algn="l"/>
             <a:r>
-              <a:rPr sz="860" b="1">
-                <a:solidFill>
-                  <a:srgbClr val="0F766E"/>
-                </a:solidFill>
-                <a:latin typeface="Noto Sans CJK SC"/>
-              </a:rPr>
-              <a:t>0606_1348 R2</a:t>
+              <a:rPr sz="860" b="0">
+                <a:solidFill>
+                  <a:srgbClr val="16A34A"/>
+                </a:solidFill>
+                <a:latin typeface="Noto Sans CJK SC"/>
+              </a:rPr>
+              <a:t>0605_0730</a:t>
             </a:r>
           </a:p>
         </p:txBody>
@@ -8930,7 +8930,7 @@
                 </a:solidFill>
                 <a:latin typeface="Noto Sans CJK SC"/>
               </a:rPr>
-              <a:t>RAW</a:t>
+              <a:t>RGB</a:t>
             </a:r>
           </a:p>
         </p:txBody>
@@ -8965,7 +8965,7 @@
                 </a:solidFill>
                 <a:latin typeface="Noto Sans CJK SC"/>
               </a:rPr>
-              <a:t>RAW-RAM LoRA repl</a:t>
+              <a:t>RGB full backbone LLRD</a:t>
             </a:r>
           </a:p>
         </p:txBody>
@@ -9000,7 +9000,7 @@
                 </a:solidFill>
                 <a:latin typeface="Noto Sans CJK SC"/>
               </a:rPr>
-              <a:t>0.8437</a:t>
+              <a:t>0.8483</a:t>
             </a:r>
           </a:p>
         </p:txBody>
@@ -9035,7 +9035,7 @@
                 </a:solidFill>
                 <a:latin typeface="Noto Sans CJK SC"/>
               </a:rPr>
-              <a:t>e3</a:t>
+              <a:t>e8</a:t>
             </a:r>
           </a:p>
         </p:txBody>
@@ -9070,7 +9070,7 @@
                 </a:solidFill>
                 <a:latin typeface="Noto Sans CJK SC"/>
               </a:rPr>
-              <a:t>6.8383</a:t>
+              <a:t>5.8880</a:t>
             </a:r>
           </a:p>
         </p:txBody>
@@ -9134,7 +9134,7 @@
           <a:p>
             <a:pPr algn="l"/>
             <a:r>
-              <a:rPr sz="860" b="1">
+              <a:rPr sz="860" b="0">
                 <a:solidFill>
                   <a:srgbClr val="6D28D9"/>
                 </a:solidFill>
@@ -9239,7 +9239,7 @@
           <a:p>
             <a:pPr algn="r"/>
             <a:r>
-              <a:rPr sz="1280" b="1">
+              <a:rPr sz="1280" b="0">
                 <a:solidFill>
                   <a:srgbClr val="1C232D"/>
                 </a:solidFill>
@@ -9309,7 +9309,7 @@
           <a:p>
             <a:pPr algn="r"/>
             <a:r>
-              <a:rPr sz="1070" b="1">
+              <a:rPr sz="1070" b="0">
                 <a:solidFill>
                   <a:srgbClr val="1C232D"/>
                 </a:solidFill>
@@ -9379,7 +9379,7 @@
           <a:p>
             <a:pPr algn="l"/>
             <a:r>
-              <a:rPr sz="860" b="1">
+              <a:rPr sz="860" b="0">
                 <a:solidFill>
                   <a:srgbClr val="B45309"/>
                 </a:solidFill>
@@ -10449,7 +10449,7 @@
           <a:p>
             <a:pPr algn="l"/>
             <a:r>
-              <a:rPr sz="860" b="1">
+              <a:rPr sz="860" b="0">
                 <a:solidFill>
                   <a:srgbClr val="6B7280"/>
                 </a:solidFill>
@@ -10694,7 +10694,7 @@
           <a:p>
             <a:pPr algn="l"/>
             <a:r>
-              <a:rPr sz="860" b="1">
+              <a:rPr sz="860" b="0">
                 <a:solidFill>
                   <a:srgbClr val="2563EB"/>
                 </a:solidFill>
@@ -10939,13 +10939,13 @@
           <a:p>
             <a:pPr algn="l"/>
             <a:r>
-              <a:rPr sz="860" b="1">
-                <a:solidFill>
-                  <a:srgbClr val="16A34A"/>
-                </a:solidFill>
-                <a:latin typeface="Noto Sans CJK SC"/>
-              </a:rPr>
-              <a:t>0608_2246</a:t>
+              <a:rPr sz="860" b="0">
+                <a:solidFill>
+                  <a:srgbClr val="0F766E"/>
+                </a:solidFill>
+                <a:latin typeface="Noto Sans CJK SC"/>
+              </a:rPr>
+              <a:t>0608_1739</a:t>
             </a:r>
           </a:p>
         </p:txBody>
@@ -10980,7 +10980,7 @@
                 </a:solidFill>
                 <a:latin typeface="Noto Sans CJK SC"/>
               </a:rPr>
-              <a:t>RGB</a:t>
+              <a:t>RAW_D</a:t>
             </a:r>
           </a:p>
         </p:txBody>
@@ -11015,7 +11015,7 @@
                 </a:solidFill>
                 <a:latin typeface="Noto Sans CJK SC"/>
               </a:rPr>
-              <a:t>RGB_Dark LoRA tap</a:t>
+              <a:t>RAW_Dark RGB16 decoder</a:t>
             </a:r>
           </a:p>
         </p:txBody>
@@ -11050,7 +11050,7 @@
                 </a:solidFill>
                 <a:latin typeface="Noto Sans CJK SC"/>
               </a:rPr>
-              <a:t>0.8555</a:t>
+              <a:t>0.8299</a:t>
             </a:r>
           </a:p>
         </p:txBody>
@@ -11085,7 +11085,7 @@
                 </a:solidFill>
                 <a:latin typeface="Noto Sans CJK SC"/>
               </a:rPr>
-              <a:t>e22</a:t>
+              <a:t>e36</a:t>
             </a:r>
           </a:p>
         </p:txBody>
@@ -11120,7 +11120,7 @@
                 </a:solidFill>
                 <a:latin typeface="Noto Sans CJK SC"/>
               </a:rPr>
-              <a:t>0.5851</a:t>
+              <a:t>0.5397</a:t>
             </a:r>
           </a:p>
         </p:txBody>
@@ -11184,13 +11184,13 @@
           <a:p>
             <a:pPr algn="l"/>
             <a:r>
-              <a:rPr sz="860" b="1">
-                <a:solidFill>
-                  <a:srgbClr val="0F766E"/>
-                </a:solidFill>
-                <a:latin typeface="Noto Sans CJK SC"/>
-              </a:rPr>
-              <a:t>0608_1739</a:t>
+              <a:rPr sz="860" b="0">
+                <a:solidFill>
+                  <a:srgbClr val="16A34A"/>
+                </a:solidFill>
+                <a:latin typeface="Noto Sans CJK SC"/>
+              </a:rPr>
+              <a:t>0608_2246</a:t>
             </a:r>
           </a:p>
         </p:txBody>
@@ -11225,7 +11225,7 @@
                 </a:solidFill>
                 <a:latin typeface="Noto Sans CJK SC"/>
               </a:rPr>
-              <a:t>RAW_D</a:t>
+              <a:t>RGB</a:t>
             </a:r>
           </a:p>
         </p:txBody>
@@ -11260,7 +11260,7 @@
                 </a:solidFill>
                 <a:latin typeface="Noto Sans CJK SC"/>
               </a:rPr>
-              <a:t>RAW_Dark RGB16 decoder</a:t>
+              <a:t>RGB_Dark LoRA tap</a:t>
             </a:r>
           </a:p>
         </p:txBody>
@@ -11295,7 +11295,7 @@
                 </a:solidFill>
                 <a:latin typeface="Noto Sans CJK SC"/>
               </a:rPr>
-              <a:t>0.8299</a:t>
+              <a:t>0.8555</a:t>
             </a:r>
           </a:p>
         </p:txBody>
@@ -11330,7 +11330,7 @@
                 </a:solidFill>
                 <a:latin typeface="Noto Sans CJK SC"/>
               </a:rPr>
-              <a:t>e36</a:t>
+              <a:t>e22</a:t>
             </a:r>
           </a:p>
         </p:txBody>
@@ -11365,7 +11365,7 @@
                 </a:solidFill>
                 <a:latin typeface="Noto Sans CJK SC"/>
               </a:rPr>
-              <a:t>0.5397</a:t>
+              <a:t>0.5851</a:t>
             </a:r>
           </a:p>
         </p:txBody>
@@ -11429,7 +11429,7 @@
           <a:p>
             <a:pPr algn="l"/>
             <a:r>
-              <a:rPr sz="860" b="1">
+              <a:rPr sz="860" b="0">
                 <a:solidFill>
                   <a:srgbClr val="0F766E"/>
                 </a:solidFill>
@@ -11674,7 +11674,7 @@
           <a:p>
             <a:pPr algn="l"/>
             <a:r>
-              <a:rPr sz="860" b="1">
+              <a:rPr sz="860" b="0">
                 <a:solidFill>
                   <a:srgbClr val="6D28D9"/>
                 </a:solidFill>
@@ -11919,7 +11919,7 @@
           <a:p>
             <a:pPr algn="l"/>
             <a:r>
-              <a:rPr sz="860" b="1">
+              <a:rPr sz="860" b="0">
                 <a:solidFill>
                   <a:srgbClr val="B45309"/>
                 </a:solidFill>
@@ -12164,7 +12164,7 @@
           <a:p>
             <a:pPr algn="l"/>
             <a:r>
-              <a:rPr sz="860" b="1">
+              <a:rPr sz="860" b="0">
                 <a:solidFill>
                   <a:srgbClr val="6D28D9"/>
                 </a:solidFill>
@@ -12269,7 +12269,7 @@
           <a:p>
             <a:pPr algn="r"/>
             <a:r>
-              <a:rPr sz="1280" b="1">
+              <a:rPr sz="1280" b="0">
                 <a:solidFill>
                   <a:srgbClr val="1C232D"/>
                 </a:solidFill>
@@ -12339,7 +12339,7 @@
           <a:p>
             <a:pPr algn="r"/>
             <a:r>
-              <a:rPr sz="1070" b="1">
+              <a:rPr sz="1070" b="0">
                 <a:solidFill>
                   <a:srgbClr val="1C232D"/>
                 </a:solidFill>
@@ -12359,7 +12359,7 @@
         <p:spPr>
           <a:xfrm>
             <a:off x="8485632" y="749808"/>
-            <a:ext cx="3310128" cy="1389888"/>
+            <a:ext cx="3310128" cy="5358384"/>
           </a:xfrm>
           <a:prstGeom prst="roundRect">
             <a:avLst>
@@ -12367,7 +12367,7 @@
             </a:avLst>
           </a:prstGeom>
           <a:solidFill>
-            <a:srgbClr val="F5F3FF"/>
+            <a:srgbClr val="FFFFFF"/>
           </a:solidFill>
           <a:ln w="8890">
             <a:solidFill>
@@ -12421,13 +12421,13 @@
           <a:p>
             <a:pPr algn="l"/>
             <a:r>
-              <a:rPr sz="1240" b="1">
+              <a:rPr sz="1160" b="1">
                 <a:solidFill>
                   <a:srgbClr val="6D28D9"/>
                 </a:solidFill>
                 <a:latin typeface="Noto Sans CJK SC"/>
               </a:rPr>
-              <a:t>扩展表最高</a:t>
+              <a:t>RAW Dark/Normal cross-eval</a:t>
             </a:r>
           </a:p>
         </p:txBody>
@@ -12440,8 +12440,8 @@
         </p:nvSpPr>
         <p:spPr>
           <a:xfrm>
-            <a:off x="8668512" y="1179576"/>
-            <a:ext cx="2907792" cy="640080"/>
+            <a:off x="8668512" y="1143000"/>
+            <a:ext cx="2944368" cy="164592"/>
           </a:xfrm>
           <a:prstGeom prst="rect">
             <a:avLst/>
@@ -12456,311 +12456,1007 @@
           <a:p>
             <a:pPr algn="l"/>
             <a:r>
-              <a:rPr sz="775" b="0">
-                <a:solidFill>
-                  <a:srgbClr val="374151"/>
-                </a:solidFill>
-                <a:latin typeface="Noto Sans CJK SC"/>
-              </a:rPr>
-              <a:t>0609_0117：RAW_Normal + LoRA + bridge/FA
-d1=0.8997，silog=0.5417</a:t>
-            </a:r>
-          </a:p>
-        </p:txBody>
-      </p:sp>
-      <p:sp>
-        <p:nvSpPr>
-          <p:cNvPr id="69" name="Rounded Rectangle 68"/>
-          <p:cNvSpPr/>
-          <p:nvPr/>
-        </p:nvSpPr>
-        <p:spPr>
-          <a:xfrm>
-            <a:off x="8485632" y="2359152"/>
-            <a:ext cx="3310128" cy="1170432"/>
-          </a:xfrm>
-          <a:prstGeom prst="roundRect">
-            <a:avLst>
-              <a:gd name="adj" fmla="val 8000"/>
-            </a:avLst>
-          </a:prstGeom>
-          <a:solidFill>
-            <a:srgbClr val="F0FDF4"/>
-          </a:solidFill>
-          <a:ln w="8890">
+              <a:rPr sz="615" b="0">
+                <a:solidFill>
+                  <a:srgbClr val="6B7280"/>
+                </a:solidFill>
+                <a:latin typeface="Noto Sans CJK SC"/>
+              </a:rPr>
+              <a:t>strict variant · D1 on 01Valid / 112 samples</a:t>
+            </a:r>
+          </a:p>
+        </p:txBody>
+      </p:sp>
+      <p:sp>
+        <p:nvSpPr>
+          <p:cNvPr id="69" name="TextBox 68"/>
+          <p:cNvSpPr txBox="1"/>
+          <p:nvPr/>
+        </p:nvSpPr>
+        <p:spPr>
+          <a:xfrm>
+            <a:off x="8668512" y="1481328"/>
+            <a:ext cx="2852928" cy="201168"/>
+          </a:xfrm>
+          <a:prstGeom prst="rect">
+            <a:avLst/>
+          </a:prstGeom>
+          <a:noFill/>
+        </p:spPr>
+        <p:txBody>
+          <a:bodyPr wrap="none" lIns="27432" rIns="27432" tIns="18288" bIns="18288" anchor="t">
+            <a:spAutoFit/>
+          </a:bodyPr>
+          <a:lstStyle/>
+          <a:p>
+            <a:pPr algn="l"/>
+            <a:r>
+              <a:rPr sz="819" b="1">
+                <a:solidFill>
+                  <a:srgbClr val="0F766E"/>
+                </a:solidFill>
+                <a:latin typeface="Noto Sans CJK SC"/>
+              </a:rPr>
+              <a:t>Canonical LoRA pair</a:t>
+            </a:r>
+          </a:p>
+        </p:txBody>
+      </p:sp>
+      <p:sp>
+        <p:nvSpPr>
+          <p:cNvPr id="70" name="TextBox 69"/>
+          <p:cNvSpPr txBox="1"/>
+          <p:nvPr/>
+        </p:nvSpPr>
+        <p:spPr>
+          <a:xfrm>
+            <a:off x="9838944" y="1755648"/>
+            <a:ext cx="713232" cy="164592"/>
+          </a:xfrm>
+          <a:prstGeom prst="rect">
+            <a:avLst/>
+          </a:prstGeom>
+          <a:noFill/>
+        </p:spPr>
+        <p:txBody>
+          <a:bodyPr wrap="none" lIns="27432" rIns="27432" tIns="18288" bIns="18288" anchor="t">
+            <a:spAutoFit/>
+          </a:bodyPr>
+          <a:lstStyle/>
+          <a:p>
+            <a:pPr algn="ctr"/>
+            <a:r>
+              <a:rPr sz="620" b="0">
+                <a:solidFill>
+                  <a:srgbClr val="6B7280"/>
+                </a:solidFill>
+                <a:latin typeface="Noto Sans CJK SC"/>
+              </a:rPr>
+              <a:t>I_dark</a:t>
+            </a:r>
+          </a:p>
+        </p:txBody>
+      </p:sp>
+      <p:sp>
+        <p:nvSpPr>
+          <p:cNvPr id="71" name="TextBox 70"/>
+          <p:cNvSpPr txBox="1"/>
+          <p:nvPr/>
+        </p:nvSpPr>
+        <p:spPr>
+          <a:xfrm>
+            <a:off x="10661904" y="1755648"/>
+            <a:ext cx="786384" cy="164592"/>
+          </a:xfrm>
+          <a:prstGeom prst="rect">
+            <a:avLst/>
+          </a:prstGeom>
+          <a:noFill/>
+        </p:spPr>
+        <p:txBody>
+          <a:bodyPr wrap="none" lIns="27432" rIns="27432" tIns="18288" bIns="18288" anchor="t">
+            <a:spAutoFit/>
+          </a:bodyPr>
+          <a:lstStyle/>
+          <a:p>
+            <a:pPr algn="ctr"/>
+            <a:r>
+              <a:rPr sz="620" b="0">
+                <a:solidFill>
+                  <a:srgbClr val="6B7280"/>
+                </a:solidFill>
+                <a:latin typeface="Noto Sans CJK SC"/>
+              </a:rPr>
+              <a:t>I_normal</a:t>
+            </a:r>
+          </a:p>
+        </p:txBody>
+      </p:sp>
+      <p:cxnSp>
+        <p:nvCxnSpPr>
+          <p:cNvPr id="72" name="Connector 71"/>
+          <p:cNvCxnSpPr/>
+          <p:nvPr/>
+        </p:nvCxnSpPr>
+        <p:spPr>
+          <a:xfrm>
+            <a:off x="8668512" y="1965960"/>
+            <a:ext cx="2852928" cy="0"/>
+          </a:xfrm>
+          <a:prstGeom prst="line">
+            <a:avLst/>
+          </a:prstGeom>
+          <a:ln w="6985">
             <a:solidFill>
-              <a:srgbClr val="D1D5DB"/>
+              <a:srgbClr val="E2E8F0"/>
             </a:solidFill>
           </a:ln>
         </p:spPr>
         <p:style>
-          <a:lnRef idx="1">
+          <a:lnRef idx="2">
             <a:schemeClr val="accent1"/>
           </a:lnRef>
-          <a:fillRef idx="3">
+          <a:fillRef idx="0">
             <a:schemeClr val="accent1"/>
           </a:fillRef>
-          <a:effectRef idx="2">
+          <a:effectRef idx="1">
             <a:schemeClr val="accent1"/>
           </a:effectRef>
           <a:fontRef idx="minor">
-            <a:schemeClr val="lt1"/>
+            <a:schemeClr val="tx1"/>
           </a:fontRef>
         </p:style>
-        <p:txBody>
-          <a:bodyPr rtlCol="0" anchor="ctr"/>
+      </p:cxnSp>
+      <p:sp>
+        <p:nvSpPr>
+          <p:cNvPr id="73" name="TextBox 72"/>
+          <p:cNvSpPr txBox="1"/>
+          <p:nvPr/>
+        </p:nvSpPr>
+        <p:spPr>
+          <a:xfrm>
+            <a:off x="8668512" y="2057400"/>
+            <a:ext cx="1060704" cy="164592"/>
+          </a:xfrm>
+          <a:prstGeom prst="rect">
+            <a:avLst/>
+          </a:prstGeom>
+          <a:noFill/>
+        </p:spPr>
+        <p:txBody>
+          <a:bodyPr wrap="none" lIns="27432" rIns="27432" tIns="18288" bIns="18288" anchor="t">
+            <a:spAutoFit/>
+          </a:bodyPr>
+          <a:lstStyle/>
+          <a:p>
+            <a:pPr algn="l"/>
+            <a:r>
+              <a:rPr sz="600" b="1">
+                <a:solidFill>
+                  <a:srgbClr val="374151"/>
+                </a:solidFill>
+                <a:latin typeface="Noto Sans CJK SC"/>
+              </a:rPr>
+              <a:t>C_dark</a:t>
+            </a:r>
+          </a:p>
+        </p:txBody>
+      </p:sp>
+      <p:sp>
+        <p:nvSpPr>
+          <p:cNvPr id="74" name="TextBox 73"/>
+          <p:cNvSpPr txBox="1"/>
+          <p:nvPr/>
+        </p:nvSpPr>
+        <p:spPr>
+          <a:xfrm>
+            <a:off x="9838944" y="2029968"/>
+            <a:ext cx="713232" cy="219456"/>
+          </a:xfrm>
+          <a:prstGeom prst="rect">
+            <a:avLst/>
+          </a:prstGeom>
+          <a:noFill/>
+        </p:spPr>
+        <p:txBody>
+          <a:bodyPr wrap="none" lIns="27432" rIns="27432" tIns="18288" bIns="18288" anchor="t">
+            <a:spAutoFit/>
+          </a:bodyPr>
           <a:lstStyle/>
           <a:p>
             <a:pPr algn="ctr"/>
-          </a:p>
-        </p:txBody>
-      </p:sp>
-      <p:sp>
-        <p:nvSpPr>
-          <p:cNvPr id="70" name="TextBox 69"/>
-          <p:cNvSpPr txBox="1"/>
-          <p:nvPr/>
-        </p:nvSpPr>
-        <p:spPr>
-          <a:xfrm>
-            <a:off x="8668512" y="2505456"/>
-            <a:ext cx="2944368" cy="201168"/>
-          </a:xfrm>
-          <a:prstGeom prst="rect">
-            <a:avLst/>
-          </a:prstGeom>
-          <a:noFill/>
-        </p:spPr>
-        <p:txBody>
-          <a:bodyPr wrap="none" lIns="27432" rIns="27432" tIns="18288" bIns="18288" anchor="t">
-            <a:spAutoFit/>
-          </a:bodyPr>
-          <a:lstStyle/>
-          <a:p>
-            <a:pPr algn="l"/>
-            <a:r>
-              <a:rPr sz="1130" b="1">
-                <a:solidFill>
-                  <a:srgbClr val="16A34A"/>
-                </a:solidFill>
-                <a:latin typeface="Noto Sans CJK SC"/>
-              </a:rPr>
-              <a:t>dark-input best</a:t>
-            </a:r>
-          </a:p>
-        </p:txBody>
-      </p:sp>
-      <p:sp>
-        <p:nvSpPr>
-          <p:cNvPr id="71" name="TextBox 70"/>
-          <p:cNvSpPr txBox="1"/>
-          <p:nvPr/>
-        </p:nvSpPr>
-        <p:spPr>
-          <a:xfrm>
-            <a:off x="8668512" y="2770632"/>
-            <a:ext cx="2907792" cy="475488"/>
-          </a:xfrm>
-          <a:prstGeom prst="rect">
-            <a:avLst/>
-          </a:prstGeom>
-          <a:noFill/>
-        </p:spPr>
-        <p:txBody>
-          <a:bodyPr wrap="none" lIns="27432" rIns="27432" tIns="18288" bIns="18288" anchor="t">
-            <a:spAutoFit/>
-          </a:bodyPr>
-          <a:lstStyle/>
-          <a:p>
-            <a:pPr algn="l"/>
-            <a:r>
-              <a:rPr sz="725" b="0">
-                <a:solidFill>
-                  <a:srgbClr val="374151"/>
-                </a:solidFill>
-                <a:latin typeface="Noto Sans CJK SC"/>
-              </a:rPr>
-              <a:t>0608_2246：RGB_Dark LoRA tap
-d1=0.8555，高于 RAW_Dark follow-up</a:t>
-            </a:r>
-          </a:p>
-        </p:txBody>
-      </p:sp>
-      <p:sp>
-        <p:nvSpPr>
-          <p:cNvPr id="72" name="Rounded Rectangle 71"/>
-          <p:cNvSpPr/>
-          <p:nvPr/>
-        </p:nvSpPr>
-        <p:spPr>
-          <a:xfrm>
-            <a:off x="8485632" y="3694176"/>
-            <a:ext cx="3310128" cy="1170432"/>
-          </a:xfrm>
-          <a:prstGeom prst="roundRect">
-            <a:avLst>
-              <a:gd name="adj" fmla="val 8000"/>
-            </a:avLst>
-          </a:prstGeom>
-          <a:solidFill>
-            <a:srgbClr val="FFFBEB"/>
-          </a:solidFill>
-          <a:ln w="8890">
+            <a:r>
+              <a:rPr sz="860" b="0">
+                <a:solidFill>
+                  <a:srgbClr val="1C232D"/>
+                </a:solidFill>
+                <a:latin typeface="Noto Sans CJK SC"/>
+              </a:rPr>
+              <a:t>0.8453</a:t>
+            </a:r>
+          </a:p>
+        </p:txBody>
+      </p:sp>
+      <p:sp>
+        <p:nvSpPr>
+          <p:cNvPr id="75" name="TextBox 74"/>
+          <p:cNvSpPr txBox="1"/>
+          <p:nvPr/>
+        </p:nvSpPr>
+        <p:spPr>
+          <a:xfrm>
+            <a:off x="10661904" y="2029968"/>
+            <a:ext cx="786384" cy="219456"/>
+          </a:xfrm>
+          <a:prstGeom prst="rect">
+            <a:avLst/>
+          </a:prstGeom>
+          <a:noFill/>
+        </p:spPr>
+        <p:txBody>
+          <a:bodyPr wrap="none" lIns="27432" rIns="27432" tIns="18288" bIns="18288" anchor="t">
+            <a:spAutoFit/>
+          </a:bodyPr>
+          <a:lstStyle/>
+          <a:p>
+            <a:pPr algn="ctr"/>
+            <a:r>
+              <a:rPr sz="860" b="0">
+                <a:solidFill>
+                  <a:srgbClr val="1C232D"/>
+                </a:solidFill>
+                <a:latin typeface="Noto Sans CJK SC"/>
+              </a:rPr>
+              <a:t>0.8805</a:t>
+            </a:r>
+          </a:p>
+        </p:txBody>
+      </p:sp>
+      <p:cxnSp>
+        <p:nvCxnSpPr>
+          <p:cNvPr id="76" name="Connector 75"/>
+          <p:cNvCxnSpPr/>
+          <p:nvPr/>
+        </p:nvCxnSpPr>
+        <p:spPr>
+          <a:xfrm>
+            <a:off x="8668512" y="2295144"/>
+            <a:ext cx="2852928" cy="0"/>
+          </a:xfrm>
+          <a:prstGeom prst="line">
+            <a:avLst/>
+          </a:prstGeom>
+          <a:ln w="5715">
             <a:solidFill>
-              <a:srgbClr val="D1D5DB"/>
+              <a:srgbClr val="F1F5F9"/>
             </a:solidFill>
           </a:ln>
         </p:spPr>
         <p:style>
-          <a:lnRef idx="1">
+          <a:lnRef idx="2">
             <a:schemeClr val="accent1"/>
           </a:lnRef>
-          <a:fillRef idx="3">
+          <a:fillRef idx="0">
             <a:schemeClr val="accent1"/>
           </a:fillRef>
-          <a:effectRef idx="2">
+          <a:effectRef idx="1">
             <a:schemeClr val="accent1"/>
           </a:effectRef>
           <a:fontRef idx="minor">
-            <a:schemeClr val="lt1"/>
+            <a:schemeClr val="tx1"/>
           </a:fontRef>
         </p:style>
-        <p:txBody>
-          <a:bodyPr rtlCol="0" anchor="ctr"/>
+      </p:cxnSp>
+      <p:sp>
+        <p:nvSpPr>
+          <p:cNvPr id="77" name="TextBox 76"/>
+          <p:cNvSpPr txBox="1"/>
+          <p:nvPr/>
+        </p:nvSpPr>
+        <p:spPr>
+          <a:xfrm>
+            <a:off x="8668512" y="2368296"/>
+            <a:ext cx="1060704" cy="164592"/>
+          </a:xfrm>
+          <a:prstGeom prst="rect">
+            <a:avLst/>
+          </a:prstGeom>
+          <a:noFill/>
+        </p:spPr>
+        <p:txBody>
+          <a:bodyPr wrap="none" lIns="27432" rIns="27432" tIns="18288" bIns="18288" anchor="t">
+            <a:spAutoFit/>
+          </a:bodyPr>
+          <a:lstStyle/>
+          <a:p>
+            <a:pPr algn="l"/>
+            <a:r>
+              <a:rPr sz="600" b="1">
+                <a:solidFill>
+                  <a:srgbClr val="374151"/>
+                </a:solidFill>
+                <a:latin typeface="Noto Sans CJK SC"/>
+              </a:rPr>
+              <a:t>C_normal</a:t>
+            </a:r>
+          </a:p>
+        </p:txBody>
+      </p:sp>
+      <p:sp>
+        <p:nvSpPr>
+          <p:cNvPr id="78" name="TextBox 77"/>
+          <p:cNvSpPr txBox="1"/>
+          <p:nvPr/>
+        </p:nvSpPr>
+        <p:spPr>
+          <a:xfrm>
+            <a:off x="9838944" y="2340864"/>
+            <a:ext cx="713232" cy="219456"/>
+          </a:xfrm>
+          <a:prstGeom prst="rect">
+            <a:avLst/>
+          </a:prstGeom>
+          <a:noFill/>
+        </p:spPr>
+        <p:txBody>
+          <a:bodyPr wrap="none" lIns="27432" rIns="27432" tIns="18288" bIns="18288" anchor="t">
+            <a:spAutoFit/>
+          </a:bodyPr>
           <a:lstStyle/>
           <a:p>
             <a:pPr algn="ctr"/>
-          </a:p>
-        </p:txBody>
-      </p:sp>
-      <p:sp>
-        <p:nvSpPr>
-          <p:cNvPr id="73" name="TextBox 72"/>
-          <p:cNvSpPr txBox="1"/>
-          <p:nvPr/>
-        </p:nvSpPr>
-        <p:spPr>
-          <a:xfrm>
-            <a:off x="8668512" y="3840480"/>
-            <a:ext cx="2944368" cy="201168"/>
-          </a:xfrm>
-          <a:prstGeom prst="rect">
-            <a:avLst/>
-          </a:prstGeom>
-          <a:noFill/>
-        </p:spPr>
-        <p:txBody>
-          <a:bodyPr wrap="none" lIns="27432" rIns="27432" tIns="18288" bIns="18288" anchor="t">
-            <a:spAutoFit/>
-          </a:bodyPr>
-          <a:lstStyle/>
-          <a:p>
-            <a:pPr algn="l"/>
-            <a:r>
-              <a:rPr sz="1130" b="1">
-                <a:solidFill>
-                  <a:srgbClr val="B45309"/>
-                </a:solidFill>
-                <a:latin typeface="Noto Sans CJK SC"/>
-              </a:rPr>
-              <a:t>RAW_Normal 影响</a:t>
-            </a:r>
-          </a:p>
-        </p:txBody>
-      </p:sp>
-      <p:sp>
-        <p:nvSpPr>
-          <p:cNvPr id="74" name="TextBox 73"/>
-          <p:cNvSpPr txBox="1"/>
-          <p:nvPr/>
-        </p:nvSpPr>
-        <p:spPr>
-          <a:xfrm>
-            <a:off x="8668512" y="4105656"/>
-            <a:ext cx="2907792" cy="475488"/>
-          </a:xfrm>
-          <a:prstGeom prst="rect">
-            <a:avLst/>
-          </a:prstGeom>
-          <a:noFill/>
-        </p:spPr>
-        <p:txBody>
-          <a:bodyPr wrap="none" lIns="27432" rIns="27432" tIns="18288" bIns="18288" anchor="t">
-            <a:spAutoFit/>
-          </a:bodyPr>
-          <a:lstStyle/>
-          <a:p>
-            <a:pPr algn="l"/>
-            <a:r>
-              <a:rPr sz="705" b="0">
-                <a:solidFill>
-                  <a:srgbClr val="374151"/>
-                </a:solidFill>
-                <a:latin typeface="Noto Sans CJK SC"/>
-              </a:rPr>
-              <a:t>0609 RAW_Normal 明显高于 matched RAW_Dark；
-这是输入源 ablation，不替代 dark-input 结论。</a:t>
-            </a:r>
-          </a:p>
-        </p:txBody>
-      </p:sp>
-      <p:sp>
-        <p:nvSpPr>
-          <p:cNvPr id="75" name="Rounded Rectangle 74"/>
-          <p:cNvSpPr/>
-          <p:nvPr/>
-        </p:nvSpPr>
-        <p:spPr>
-          <a:xfrm>
-            <a:off x="8485632" y="5065776"/>
-            <a:ext cx="3310128" cy="1042415"/>
-          </a:xfrm>
-          <a:prstGeom prst="roundRect">
-            <a:avLst>
-              <a:gd name="adj" fmla="val 8000"/>
-            </a:avLst>
-          </a:prstGeom>
-          <a:solidFill>
-            <a:srgbClr val="EFF6FF"/>
-          </a:solidFill>
-          <a:ln w="8890">
+            <a:r>
+              <a:rPr sz="860" b="0">
+                <a:solidFill>
+                  <a:srgbClr val="1C232D"/>
+                </a:solidFill>
+                <a:latin typeface="Noto Sans CJK SC"/>
+              </a:rPr>
+              <a:t>0.8170</a:t>
+            </a:r>
+          </a:p>
+        </p:txBody>
+      </p:sp>
+      <p:sp>
+        <p:nvSpPr>
+          <p:cNvPr id="79" name="TextBox 78"/>
+          <p:cNvSpPr txBox="1"/>
+          <p:nvPr/>
+        </p:nvSpPr>
+        <p:spPr>
+          <a:xfrm>
+            <a:off x="10661904" y="2340864"/>
+            <a:ext cx="786384" cy="219456"/>
+          </a:xfrm>
+          <a:prstGeom prst="rect">
+            <a:avLst/>
+          </a:prstGeom>
+          <a:noFill/>
+        </p:spPr>
+        <p:txBody>
+          <a:bodyPr wrap="none" lIns="27432" rIns="27432" tIns="18288" bIns="18288" anchor="t">
+            <a:spAutoFit/>
+          </a:bodyPr>
+          <a:lstStyle/>
+          <a:p>
+            <a:pPr algn="ctr"/>
+            <a:r>
+              <a:rPr sz="860" b="0">
+                <a:solidFill>
+                  <a:srgbClr val="1C232D"/>
+                </a:solidFill>
+                <a:latin typeface="Noto Sans CJK SC"/>
+              </a:rPr>
+              <a:t>0.8989</a:t>
+            </a:r>
+          </a:p>
+        </p:txBody>
+      </p:sp>
+      <p:cxnSp>
+        <p:nvCxnSpPr>
+          <p:cNvPr id="80" name="Connector 79"/>
+          <p:cNvCxnSpPr/>
+          <p:nvPr/>
+        </p:nvCxnSpPr>
+        <p:spPr>
+          <a:xfrm>
+            <a:off x="8668512" y="2606040"/>
+            <a:ext cx="2852928" cy="0"/>
+          </a:xfrm>
+          <a:prstGeom prst="line">
+            <a:avLst/>
+          </a:prstGeom>
+          <a:ln w="5715">
             <a:solidFill>
-              <a:srgbClr val="D1D5DB"/>
+              <a:srgbClr val="F1F5F9"/>
             </a:solidFill>
           </a:ln>
         </p:spPr>
         <p:style>
-          <a:lnRef idx="1">
+          <a:lnRef idx="2">
             <a:schemeClr val="accent1"/>
           </a:lnRef>
-          <a:fillRef idx="3">
+          <a:fillRef idx="0">
             <a:schemeClr val="accent1"/>
           </a:fillRef>
-          <a:effectRef idx="2">
+          <a:effectRef idx="1">
             <a:schemeClr val="accent1"/>
           </a:effectRef>
           <a:fontRef idx="minor">
-            <a:schemeClr val="lt1"/>
+            <a:schemeClr val="tx1"/>
           </a:fontRef>
         </p:style>
-        <p:txBody>
-          <a:bodyPr rtlCol="0" anchor="ctr"/>
+      </p:cxnSp>
+      <p:sp>
+        <p:nvSpPr>
+          <p:cNvPr id="81" name="TextBox 80"/>
+          <p:cNvSpPr txBox="1"/>
+          <p:nvPr/>
+        </p:nvSpPr>
+        <p:spPr>
+          <a:xfrm>
+            <a:off x="8668512" y="2724912"/>
+            <a:ext cx="2852928" cy="237744"/>
+          </a:xfrm>
+          <a:prstGeom prst="rect">
+            <a:avLst/>
+          </a:prstGeom>
+          <a:noFill/>
+        </p:spPr>
+        <p:txBody>
+          <a:bodyPr wrap="none" lIns="27432" rIns="27432" tIns="18288" bIns="18288" anchor="t">
+            <a:spAutoFit/>
+          </a:bodyPr>
+          <a:lstStyle/>
+          <a:p>
+            <a:pPr algn="l"/>
+            <a:r>
+              <a:rPr sz="580" b="0">
+                <a:solidFill>
+                  <a:srgbClr val="374151"/>
+                </a:solidFill>
+                <a:latin typeface="Noto Sans CJK SC"/>
+              </a:rPr>
+              <a:t>G=0.053667 · R_DN=65.7% · ΔDN=+0.035253 · ΔND=-0.028307</a:t>
+            </a:r>
+          </a:p>
+        </p:txBody>
+      </p:sp>
+      <p:sp>
+        <p:nvSpPr>
+          <p:cNvPr id="82" name="TextBox 81"/>
+          <p:cNvSpPr txBox="1"/>
+          <p:nvPr/>
+        </p:nvSpPr>
+        <p:spPr>
+          <a:xfrm>
+            <a:off x="8668512" y="3127248"/>
+            <a:ext cx="2852928" cy="201168"/>
+          </a:xfrm>
+          <a:prstGeom prst="rect">
+            <a:avLst/>
+          </a:prstGeom>
+          <a:noFill/>
+        </p:spPr>
+        <p:txBody>
+          <a:bodyPr wrap="none" lIns="27432" rIns="27432" tIns="18288" bIns="18288" anchor="t">
+            <a:spAutoFit/>
+          </a:bodyPr>
+          <a:lstStyle/>
+          <a:p>
+            <a:pPr algn="l"/>
+            <a:r>
+              <a:rPr sz="819" b="1">
+                <a:solidFill>
+                  <a:srgbClr val="B45309"/>
+                </a:solidFill>
+                <a:latin typeface="Noto Sans CJK SC"/>
+              </a:rPr>
+              <a:t>W0 decoder-only sanity</a:t>
+            </a:r>
+          </a:p>
+        </p:txBody>
+      </p:sp>
+      <p:sp>
+        <p:nvSpPr>
+          <p:cNvPr id="83" name="TextBox 82"/>
+          <p:cNvSpPr txBox="1"/>
+          <p:nvPr/>
+        </p:nvSpPr>
+        <p:spPr>
+          <a:xfrm>
+            <a:off x="9838944" y="3401568"/>
+            <a:ext cx="713232" cy="164592"/>
+          </a:xfrm>
+          <a:prstGeom prst="rect">
+            <a:avLst/>
+          </a:prstGeom>
+          <a:noFill/>
+        </p:spPr>
+        <p:txBody>
+          <a:bodyPr wrap="none" lIns="27432" rIns="27432" tIns="18288" bIns="18288" anchor="t">
+            <a:spAutoFit/>
+          </a:bodyPr>
           <a:lstStyle/>
           <a:p>
             <a:pPr algn="ctr"/>
-          </a:p>
-        </p:txBody>
-      </p:sp>
-      <p:sp>
-        <p:nvSpPr>
-          <p:cNvPr id="76" name="TextBox 75"/>
+            <a:r>
+              <a:rPr sz="620" b="0">
+                <a:solidFill>
+                  <a:srgbClr val="6B7280"/>
+                </a:solidFill>
+                <a:latin typeface="Noto Sans CJK SC"/>
+              </a:rPr>
+              <a:t>I_dark</a:t>
+            </a:r>
+          </a:p>
+        </p:txBody>
+      </p:sp>
+      <p:sp>
+        <p:nvSpPr>
+          <p:cNvPr id="84" name="TextBox 83"/>
+          <p:cNvSpPr txBox="1"/>
+          <p:nvPr/>
+        </p:nvSpPr>
+        <p:spPr>
+          <a:xfrm>
+            <a:off x="10661904" y="3401568"/>
+            <a:ext cx="786384" cy="164592"/>
+          </a:xfrm>
+          <a:prstGeom prst="rect">
+            <a:avLst/>
+          </a:prstGeom>
+          <a:noFill/>
+        </p:spPr>
+        <p:txBody>
+          <a:bodyPr wrap="none" lIns="27432" rIns="27432" tIns="18288" bIns="18288" anchor="t">
+            <a:spAutoFit/>
+          </a:bodyPr>
+          <a:lstStyle/>
+          <a:p>
+            <a:pPr algn="ctr"/>
+            <a:r>
+              <a:rPr sz="620" b="0">
+                <a:solidFill>
+                  <a:srgbClr val="6B7280"/>
+                </a:solidFill>
+                <a:latin typeface="Noto Sans CJK SC"/>
+              </a:rPr>
+              <a:t>I_normal</a:t>
+            </a:r>
+          </a:p>
+        </p:txBody>
+      </p:sp>
+      <p:cxnSp>
+        <p:nvCxnSpPr>
+          <p:cNvPr id="85" name="Connector 84"/>
+          <p:cNvCxnSpPr/>
+          <p:nvPr/>
+        </p:nvCxnSpPr>
+        <p:spPr>
+          <a:xfrm>
+            <a:off x="8668512" y="3611880"/>
+            <a:ext cx="2852928" cy="0"/>
+          </a:xfrm>
+          <a:prstGeom prst="line">
+            <a:avLst/>
+          </a:prstGeom>
+          <a:ln w="6985">
+            <a:solidFill>
+              <a:srgbClr val="E2E8F0"/>
+            </a:solidFill>
+          </a:ln>
+        </p:spPr>
+        <p:style>
+          <a:lnRef idx="2">
+            <a:schemeClr val="accent1"/>
+          </a:lnRef>
+          <a:fillRef idx="0">
+            <a:schemeClr val="accent1"/>
+          </a:fillRef>
+          <a:effectRef idx="1">
+            <a:schemeClr val="accent1"/>
+          </a:effectRef>
+          <a:fontRef idx="minor">
+            <a:schemeClr val="tx1"/>
+          </a:fontRef>
+        </p:style>
+      </p:cxnSp>
+      <p:sp>
+        <p:nvSpPr>
+          <p:cNvPr id="86" name="TextBox 85"/>
+          <p:cNvSpPr txBox="1"/>
+          <p:nvPr/>
+        </p:nvSpPr>
+        <p:spPr>
+          <a:xfrm>
+            <a:off x="8668512" y="3703320"/>
+            <a:ext cx="1060704" cy="164592"/>
+          </a:xfrm>
+          <a:prstGeom prst="rect">
+            <a:avLst/>
+          </a:prstGeom>
+          <a:noFill/>
+        </p:spPr>
+        <p:txBody>
+          <a:bodyPr wrap="none" lIns="27432" rIns="27432" tIns="18288" bIns="18288" anchor="t">
+            <a:spAutoFit/>
+          </a:bodyPr>
+          <a:lstStyle/>
+          <a:p>
+            <a:pPr algn="l"/>
+            <a:r>
+              <a:rPr sz="600" b="1">
+                <a:solidFill>
+                  <a:srgbClr val="374151"/>
+                </a:solidFill>
+                <a:latin typeface="Noto Sans CJK SC"/>
+              </a:rPr>
+              <a:t>C_dark_W0</a:t>
+            </a:r>
+          </a:p>
+        </p:txBody>
+      </p:sp>
+      <p:sp>
+        <p:nvSpPr>
+          <p:cNvPr id="87" name="TextBox 86"/>
+          <p:cNvSpPr txBox="1"/>
+          <p:nvPr/>
+        </p:nvSpPr>
+        <p:spPr>
+          <a:xfrm>
+            <a:off x="9838944" y="3675887"/>
+            <a:ext cx="713232" cy="219456"/>
+          </a:xfrm>
+          <a:prstGeom prst="rect">
+            <a:avLst/>
+          </a:prstGeom>
+          <a:noFill/>
+        </p:spPr>
+        <p:txBody>
+          <a:bodyPr wrap="none" lIns="27432" rIns="27432" tIns="18288" bIns="18288" anchor="t">
+            <a:spAutoFit/>
+          </a:bodyPr>
+          <a:lstStyle/>
+          <a:p>
+            <a:pPr algn="ctr"/>
+            <a:r>
+              <a:rPr sz="860" b="0">
+                <a:solidFill>
+                  <a:srgbClr val="1C232D"/>
+                </a:solidFill>
+                <a:latin typeface="Noto Sans CJK SC"/>
+              </a:rPr>
+              <a:t>0.8297</a:t>
+            </a:r>
+          </a:p>
+        </p:txBody>
+      </p:sp>
+      <p:sp>
+        <p:nvSpPr>
+          <p:cNvPr id="88" name="TextBox 87"/>
+          <p:cNvSpPr txBox="1"/>
+          <p:nvPr/>
+        </p:nvSpPr>
+        <p:spPr>
+          <a:xfrm>
+            <a:off x="10661904" y="3675887"/>
+            <a:ext cx="786384" cy="219456"/>
+          </a:xfrm>
+          <a:prstGeom prst="rect">
+            <a:avLst/>
+          </a:prstGeom>
+          <a:noFill/>
+        </p:spPr>
+        <p:txBody>
+          <a:bodyPr wrap="none" lIns="27432" rIns="27432" tIns="18288" bIns="18288" anchor="t">
+            <a:spAutoFit/>
+          </a:bodyPr>
+          <a:lstStyle/>
+          <a:p>
+            <a:pPr algn="ctr"/>
+            <a:r>
+              <a:rPr sz="860" b="0">
+                <a:solidFill>
+                  <a:srgbClr val="1C232D"/>
+                </a:solidFill>
+                <a:latin typeface="Noto Sans CJK SC"/>
+              </a:rPr>
+              <a:t>0.8760</a:t>
+            </a:r>
+          </a:p>
+        </p:txBody>
+      </p:sp>
+      <p:cxnSp>
+        <p:nvCxnSpPr>
+          <p:cNvPr id="89" name="Connector 88"/>
+          <p:cNvCxnSpPr/>
+          <p:nvPr/>
+        </p:nvCxnSpPr>
+        <p:spPr>
+          <a:xfrm>
+            <a:off x="8668512" y="3941063"/>
+            <a:ext cx="2852928" cy="0"/>
+          </a:xfrm>
+          <a:prstGeom prst="line">
+            <a:avLst/>
+          </a:prstGeom>
+          <a:ln w="5715">
+            <a:solidFill>
+              <a:srgbClr val="F1F5F9"/>
+            </a:solidFill>
+          </a:ln>
+        </p:spPr>
+        <p:style>
+          <a:lnRef idx="2">
+            <a:schemeClr val="accent1"/>
+          </a:lnRef>
+          <a:fillRef idx="0">
+            <a:schemeClr val="accent1"/>
+          </a:fillRef>
+          <a:effectRef idx="1">
+            <a:schemeClr val="accent1"/>
+          </a:effectRef>
+          <a:fontRef idx="minor">
+            <a:schemeClr val="tx1"/>
+          </a:fontRef>
+        </p:style>
+      </p:cxnSp>
+      <p:sp>
+        <p:nvSpPr>
+          <p:cNvPr id="90" name="TextBox 89"/>
+          <p:cNvSpPr txBox="1"/>
+          <p:nvPr/>
+        </p:nvSpPr>
+        <p:spPr>
+          <a:xfrm>
+            <a:off x="8668512" y="4014215"/>
+            <a:ext cx="1060704" cy="164592"/>
+          </a:xfrm>
+          <a:prstGeom prst="rect">
+            <a:avLst/>
+          </a:prstGeom>
+          <a:noFill/>
+        </p:spPr>
+        <p:txBody>
+          <a:bodyPr wrap="none" lIns="27432" rIns="27432" tIns="18288" bIns="18288" anchor="t">
+            <a:spAutoFit/>
+          </a:bodyPr>
+          <a:lstStyle/>
+          <a:p>
+            <a:pPr algn="l"/>
+            <a:r>
+              <a:rPr sz="600" b="1">
+                <a:solidFill>
+                  <a:srgbClr val="374151"/>
+                </a:solidFill>
+                <a:latin typeface="Noto Sans CJK SC"/>
+              </a:rPr>
+              <a:t>C_normal_W0</a:t>
+            </a:r>
+          </a:p>
+        </p:txBody>
+      </p:sp>
+      <p:sp>
+        <p:nvSpPr>
+          <p:cNvPr id="91" name="TextBox 90"/>
+          <p:cNvSpPr txBox="1"/>
+          <p:nvPr/>
+        </p:nvSpPr>
+        <p:spPr>
+          <a:xfrm>
+            <a:off x="9838944" y="3986783"/>
+            <a:ext cx="713232" cy="219456"/>
+          </a:xfrm>
+          <a:prstGeom prst="rect">
+            <a:avLst/>
+          </a:prstGeom>
+          <a:noFill/>
+        </p:spPr>
+        <p:txBody>
+          <a:bodyPr wrap="none" lIns="27432" rIns="27432" tIns="18288" bIns="18288" anchor="t">
+            <a:spAutoFit/>
+          </a:bodyPr>
+          <a:lstStyle/>
+          <a:p>
+            <a:pPr algn="ctr"/>
+            <a:r>
+              <a:rPr sz="860" b="0">
+                <a:solidFill>
+                  <a:srgbClr val="1C232D"/>
+                </a:solidFill>
+                <a:latin typeface="Noto Sans CJK SC"/>
+              </a:rPr>
+              <a:t>0.7928</a:t>
+            </a:r>
+          </a:p>
+        </p:txBody>
+      </p:sp>
+      <p:sp>
+        <p:nvSpPr>
+          <p:cNvPr id="92" name="TextBox 91"/>
+          <p:cNvSpPr txBox="1"/>
+          <p:nvPr/>
+        </p:nvSpPr>
+        <p:spPr>
+          <a:xfrm>
+            <a:off x="10661904" y="3986783"/>
+            <a:ext cx="786384" cy="219456"/>
+          </a:xfrm>
+          <a:prstGeom prst="rect">
+            <a:avLst/>
+          </a:prstGeom>
+          <a:noFill/>
+        </p:spPr>
+        <p:txBody>
+          <a:bodyPr wrap="none" lIns="27432" rIns="27432" tIns="18288" bIns="18288" anchor="t">
+            <a:spAutoFit/>
+          </a:bodyPr>
+          <a:lstStyle/>
+          <a:p>
+            <a:pPr algn="ctr"/>
+            <a:r>
+              <a:rPr sz="860" b="0">
+                <a:solidFill>
+                  <a:srgbClr val="1C232D"/>
+                </a:solidFill>
+                <a:latin typeface="Noto Sans CJK SC"/>
+              </a:rPr>
+              <a:t>0.8871</a:t>
+            </a:r>
+          </a:p>
+        </p:txBody>
+      </p:sp>
+      <p:cxnSp>
+        <p:nvCxnSpPr>
+          <p:cNvPr id="93" name="Connector 92"/>
+          <p:cNvCxnSpPr/>
+          <p:nvPr/>
+        </p:nvCxnSpPr>
+        <p:spPr>
+          <a:xfrm>
+            <a:off x="8668512" y="4251959"/>
+            <a:ext cx="2852928" cy="0"/>
+          </a:xfrm>
+          <a:prstGeom prst="line">
+            <a:avLst/>
+          </a:prstGeom>
+          <a:ln w="5715">
+            <a:solidFill>
+              <a:srgbClr val="F1F5F9"/>
+            </a:solidFill>
+          </a:ln>
+        </p:spPr>
+        <p:style>
+          <a:lnRef idx="2">
+            <a:schemeClr val="accent1"/>
+          </a:lnRef>
+          <a:fillRef idx="0">
+            <a:schemeClr val="accent1"/>
+          </a:fillRef>
+          <a:effectRef idx="1">
+            <a:schemeClr val="accent1"/>
+          </a:effectRef>
+          <a:fontRef idx="minor">
+            <a:schemeClr val="tx1"/>
+          </a:fontRef>
+        </p:style>
+      </p:cxnSp>
+      <p:sp>
+        <p:nvSpPr>
+          <p:cNvPr id="94" name="TextBox 93"/>
+          <p:cNvSpPr txBox="1"/>
+          <p:nvPr/>
+        </p:nvSpPr>
+        <p:spPr>
+          <a:xfrm>
+            <a:off x="8668512" y="4370832"/>
+            <a:ext cx="2852928" cy="237744"/>
+          </a:xfrm>
+          <a:prstGeom prst="rect">
+            <a:avLst/>
+          </a:prstGeom>
+          <a:noFill/>
+        </p:spPr>
+        <p:txBody>
+          <a:bodyPr wrap="none" lIns="27432" rIns="27432" tIns="18288" bIns="18288" anchor="t">
+            <a:spAutoFit/>
+          </a:bodyPr>
+          <a:lstStyle/>
+          <a:p>
+            <a:pPr algn="l"/>
+            <a:r>
+              <a:rPr sz="580" b="0">
+                <a:solidFill>
+                  <a:srgbClr val="374151"/>
+                </a:solidFill>
+                <a:latin typeface="Noto Sans CJK SC"/>
+              </a:rPr>
+              <a:t>G=0.057380 · R_DN=80.6% · ΔDN=+0.046256 · ΔND=-0.036889</a:t>
+            </a:r>
+          </a:p>
+        </p:txBody>
+      </p:sp>
+      <p:cxnSp>
+        <p:nvCxnSpPr>
+          <p:cNvPr id="95" name="Connector 94"/>
+          <p:cNvCxnSpPr/>
+          <p:nvPr/>
+        </p:nvCxnSpPr>
+        <p:spPr>
+          <a:xfrm>
+            <a:off x="8668512" y="4791456"/>
+            <a:ext cx="2852928" cy="0"/>
+          </a:xfrm>
+          <a:prstGeom prst="line">
+            <a:avLst/>
+          </a:prstGeom>
+          <a:ln w="6985">
+            <a:solidFill>
+              <a:srgbClr val="E2E8F0"/>
+            </a:solidFill>
+          </a:ln>
+        </p:spPr>
+        <p:style>
+          <a:lnRef idx="2">
+            <a:schemeClr val="accent1"/>
+          </a:lnRef>
+          <a:fillRef idx="0">
+            <a:schemeClr val="accent1"/>
+          </a:fillRef>
+          <a:effectRef idx="1">
+            <a:schemeClr val="accent1"/>
+          </a:effectRef>
+          <a:fontRef idx="minor">
+            <a:schemeClr val="tx1"/>
+          </a:fontRef>
+        </p:style>
+      </p:cxnSp>
+      <p:sp>
+        <p:nvSpPr>
+          <p:cNvPr id="96" name="TextBox 95"/>
+          <p:cNvSpPr txBox="1"/>
+          <p:nvPr/>
+        </p:nvSpPr>
+        <p:spPr>
+          <a:xfrm>
+            <a:off x="8668512" y="4956048"/>
+            <a:ext cx="2852928" cy="201168"/>
+          </a:xfrm>
+          <a:prstGeom prst="rect">
+            <a:avLst/>
+          </a:prstGeom>
+          <a:noFill/>
+        </p:spPr>
+        <p:txBody>
+          <a:bodyPr wrap="none" lIns="27432" rIns="27432" tIns="18288" bIns="18288" anchor="t">
+            <a:spAutoFit/>
+          </a:bodyPr>
+          <a:lstStyle/>
+          <a:p>
+            <a:pPr algn="l"/>
+            <a:r>
+              <a:rPr sz="860" b="1">
+                <a:solidFill>
+                  <a:srgbClr val="2563EB"/>
+                </a:solidFill>
+                <a:latin typeface="Noto Sans CJK SC"/>
+              </a:rPr>
+              <a:t>读法</a:t>
+            </a:r>
+          </a:p>
+        </p:txBody>
+      </p:sp>
+      <p:sp>
+        <p:nvSpPr>
+          <p:cNvPr id="97" name="TextBox 96"/>
           <p:cNvSpPr txBox="1"/>
           <p:nvPr/>
         </p:nvSpPr>
         <p:spPr>
           <a:xfrm>
             <a:off x="8668512" y="5193792"/>
-            <a:ext cx="2944368" cy="201168"/>
+            <a:ext cx="2852928" cy="438912"/>
           </a:xfrm>
           <a:prstGeom prst="rect">
             <a:avLst/>
@@ -12775,27 +13471,28 @@
           <a:p>
             <a:pPr algn="l"/>
             <a:r>
-              <a:rPr sz="1100" b="1">
-                <a:solidFill>
-                  <a:srgbClr val="2563EB"/>
-                </a:solidFill>
-                <a:latin typeface="Noto Sans CJK SC"/>
-              </a:rPr>
-              <a:t>读数口径</a:t>
-            </a:r>
-          </a:p>
-        </p:txBody>
-      </p:sp>
-      <p:sp>
-        <p:nvSpPr>
-          <p:cNvPr id="77" name="TextBox 76"/>
-          <p:cNvSpPr txBox="1"/>
-          <p:nvPr/>
-        </p:nvSpPr>
-        <p:spPr>
-          <a:xfrm>
-            <a:off x="8668512" y="5431536"/>
-            <a:ext cx="2907792" cy="438912"/>
+              <a:rPr sz="590" b="0">
+                <a:solidFill>
+                  <a:srgbClr val="374151"/>
+                </a:solidFill>
+                <a:latin typeface="Noto Sans CJK SC"/>
+              </a:rPr>
+              <a:t>C_dark(I_normal) recovers most, but not all, of the canonical gap.
+C_normal(I_dark) &lt; C_dark(I_dark), so normal checkpoint is not robust to RAW_dark.</a:t>
+            </a:r>
+          </a:p>
+        </p:txBody>
+      </p:sp>
+      <p:sp>
+        <p:nvSpPr>
+          <p:cNvPr id="98" name="TextBox 97"/>
+          <p:cNvSpPr txBox="1"/>
+          <p:nvPr/>
+        </p:nvSpPr>
+        <p:spPr>
+          <a:xfrm>
+            <a:off x="8668512" y="5815584"/>
+            <a:ext cx="2852928" cy="146304"/>
           </a:xfrm>
           <a:prstGeom prst="rect">
             <a:avLst/>
@@ -12810,21 +13507,20 @@
           <a:p>
             <a:pPr algn="l"/>
             <a:r>
-              <a:rPr sz="700" b="0">
-                <a:solidFill>
-                  <a:srgbClr val="374151"/>
-                </a:solidFill>
-                <a:latin typeface="Noto Sans CJK SC"/>
-              </a:rPr>
-              <a:t>d1 越高越好；silog 越低越好。
-silog 与 best d1 取同一 epoch。</a:t>
-            </a:r>
-          </a:p>
-        </p:txBody>
-      </p:sp>
-      <p:sp>
-        <p:nvSpPr>
-          <p:cNvPr id="78" name="TextBox 77"/>
+              <a:rPr sz="509" b="0">
+                <a:solidFill>
+                  <a:srgbClr val="6B7280"/>
+                </a:solidFill>
+                <a:latin typeface="Noto Sans CJK SC"/>
+              </a:rPr>
+              <a:t>source: plans/0609/lod_raw_cross_eval_combined_report.md</a:t>
+            </a:r>
+          </a:p>
+        </p:txBody>
+      </p:sp>
+      <p:sp>
+        <p:nvSpPr>
+          <p:cNvPr id="99" name="TextBox 98"/>
           <p:cNvSpPr txBox="1"/>
           <p:nvPr/>
         </p:nvSpPr>

</xml_diff>